<commit_message>
added links to fuzzing
</commit_message>
<xml_diff>
--- a/fuzzing.pptx
+++ b/fuzzing.pptx
@@ -205,7 +205,7 @@
           <a:p>
             <a:fld id="{681946D7-9ACD-5741-9A93-6BC3A876858B}" type="datetimeFigureOut">
               <a:rPr lang="en-US" smtClean="0"/>
-              <a:t>2/10/20</a:t>
+              <a:t>2/12/20</a:t>
             </a:fld>
             <a:endParaRPr lang="en-US"/>
           </a:p>
@@ -703,7 +703,7 @@
           <a:p>
             <a:fld id="{F7C34817-32A6-8B49-A0F9-E5B31E458402}" type="datetimeFigureOut">
               <a:rPr lang="en-US" smtClean="0"/>
-              <a:t>2/10/20</a:t>
+              <a:t>2/12/20</a:t>
             </a:fld>
             <a:endParaRPr lang="en-US"/>
           </a:p>
@@ -901,7 +901,7 @@
           <a:p>
             <a:fld id="{F7C34817-32A6-8B49-A0F9-E5B31E458402}" type="datetimeFigureOut">
               <a:rPr lang="en-US" smtClean="0"/>
-              <a:t>2/10/20</a:t>
+              <a:t>2/12/20</a:t>
             </a:fld>
             <a:endParaRPr lang="en-US"/>
           </a:p>
@@ -1109,7 +1109,7 @@
           <a:p>
             <a:fld id="{F7C34817-32A6-8B49-A0F9-E5B31E458402}" type="datetimeFigureOut">
               <a:rPr lang="en-US" smtClean="0"/>
-              <a:t>2/10/20</a:t>
+              <a:t>2/12/20</a:t>
             </a:fld>
             <a:endParaRPr lang="en-US"/>
           </a:p>
@@ -1307,7 +1307,7 @@
           <a:p>
             <a:fld id="{F7C34817-32A6-8B49-A0F9-E5B31E458402}" type="datetimeFigureOut">
               <a:rPr lang="en-US" smtClean="0"/>
-              <a:t>2/10/20</a:t>
+              <a:t>2/12/20</a:t>
             </a:fld>
             <a:endParaRPr lang="en-US"/>
           </a:p>
@@ -1582,7 +1582,7 @@
           <a:p>
             <a:fld id="{F7C34817-32A6-8B49-A0F9-E5B31E458402}" type="datetimeFigureOut">
               <a:rPr lang="en-US" smtClean="0"/>
-              <a:t>2/10/20</a:t>
+              <a:t>2/12/20</a:t>
             </a:fld>
             <a:endParaRPr lang="en-US"/>
           </a:p>
@@ -1847,7 +1847,7 @@
           <a:p>
             <a:fld id="{F7C34817-32A6-8B49-A0F9-E5B31E458402}" type="datetimeFigureOut">
               <a:rPr lang="en-US" smtClean="0"/>
-              <a:t>2/10/20</a:t>
+              <a:t>2/12/20</a:t>
             </a:fld>
             <a:endParaRPr lang="en-US"/>
           </a:p>
@@ -2259,7 +2259,7 @@
           <a:p>
             <a:fld id="{F7C34817-32A6-8B49-A0F9-E5B31E458402}" type="datetimeFigureOut">
               <a:rPr lang="en-US" smtClean="0"/>
-              <a:t>2/10/20</a:t>
+              <a:t>2/12/20</a:t>
             </a:fld>
             <a:endParaRPr lang="en-US"/>
           </a:p>
@@ -2400,7 +2400,7 @@
           <a:p>
             <a:fld id="{F7C34817-32A6-8B49-A0F9-E5B31E458402}" type="datetimeFigureOut">
               <a:rPr lang="en-US" smtClean="0"/>
-              <a:t>2/10/20</a:t>
+              <a:t>2/12/20</a:t>
             </a:fld>
             <a:endParaRPr lang="en-US"/>
           </a:p>
@@ -2513,7 +2513,7 @@
           <a:p>
             <a:fld id="{F7C34817-32A6-8B49-A0F9-E5B31E458402}" type="datetimeFigureOut">
               <a:rPr lang="en-US" smtClean="0"/>
-              <a:t>2/10/20</a:t>
+              <a:t>2/12/20</a:t>
             </a:fld>
             <a:endParaRPr lang="en-US"/>
           </a:p>
@@ -2824,7 +2824,7 @@
           <a:p>
             <a:fld id="{F7C34817-32A6-8B49-A0F9-E5B31E458402}" type="datetimeFigureOut">
               <a:rPr lang="en-US" smtClean="0"/>
-              <a:t>2/10/20</a:t>
+              <a:t>2/12/20</a:t>
             </a:fld>
             <a:endParaRPr lang="en-US"/>
           </a:p>
@@ -3112,7 +3112,7 @@
           <a:p>
             <a:fld id="{F7C34817-32A6-8B49-A0F9-E5B31E458402}" type="datetimeFigureOut">
               <a:rPr lang="en-US" smtClean="0"/>
-              <a:t>2/10/20</a:t>
+              <a:t>2/12/20</a:t>
             </a:fld>
             <a:endParaRPr lang="en-US"/>
           </a:p>
@@ -3353,7 +3353,7 @@
           <a:p>
             <a:fld id="{F7C34817-32A6-8B49-A0F9-E5B31E458402}" type="datetimeFigureOut">
               <a:rPr lang="en-US" smtClean="0"/>
-              <a:t>2/10/20</a:t>
+              <a:t>2/12/20</a:t>
             </a:fld>
             <a:endParaRPr lang="en-US"/>
           </a:p>
@@ -7133,8 +7133,8 @@
         </p:nvSpPr>
         <p:spPr>
           <a:xfrm>
-            <a:off x="96460" y="652527"/>
-            <a:ext cx="11992304" cy="5755422"/>
+            <a:off x="199696" y="106837"/>
+            <a:ext cx="11992304" cy="3539430"/>
           </a:xfrm>
           <a:prstGeom prst="rect">
             <a:avLst/>
@@ -7148,389 +7148,419 @@
           <a:lstStyle/>
           <a:p>
             <a:r>
-              <a:rPr lang="en-US" sz="1600" dirty="0"/>
-              <a:t>A systematic review of fuzzing based on machine learning techniques – by Yan </a:t>
-            </a:r>
-            <a:r>
-              <a:rPr lang="en-US" sz="1600" dirty="0" err="1"/>
+              <a:rPr lang="en-US" sz="1400" dirty="0"/>
+              <a:t>* A systematic review of fuzzing based on machine learning techniques – by Yan </a:t>
+            </a:r>
+            <a:r>
+              <a:rPr lang="en-US" sz="1400" dirty="0" err="1"/>
               <a:t>Wanga</a:t>
             </a:r>
             <a:r>
-              <a:rPr lang="en-US" sz="1600" dirty="0"/>
+              <a:rPr lang="en-US" sz="1400" dirty="0"/>
               <a:t>, Peng </a:t>
             </a:r>
             <a:r>
-              <a:rPr lang="en-US" sz="1600" dirty="0" err="1"/>
+              <a:rPr lang="en-US" sz="1400" dirty="0" err="1"/>
               <a:t>Jiaa</a:t>
             </a:r>
             <a:r>
-              <a:rPr lang="en-US" sz="1600" dirty="0"/>
+              <a:rPr lang="en-US" sz="1400" dirty="0"/>
               <a:t>, </a:t>
             </a:r>
             <a:r>
-              <a:rPr lang="en-US" sz="1600" dirty="0" err="1"/>
+              <a:rPr lang="en-US" sz="1400" dirty="0" err="1"/>
               <a:t>Luping</a:t>
             </a:r>
             <a:r>
-              <a:rPr lang="en-US" sz="1600" dirty="0"/>
+              <a:rPr lang="en-US" sz="1400" dirty="0"/>
               <a:t> </a:t>
             </a:r>
             <a:r>
-              <a:rPr lang="en-US" sz="1600" dirty="0" err="1"/>
+              <a:rPr lang="en-US" sz="1400" dirty="0" err="1"/>
               <a:t>Liub</a:t>
             </a:r>
             <a:r>
-              <a:rPr lang="en-US" sz="1600" dirty="0"/>
+              <a:rPr lang="en-US" sz="1400" dirty="0"/>
               <a:t>, </a:t>
             </a:r>
             <a:r>
-              <a:rPr lang="en-US" sz="1600" dirty="0" err="1"/>
+              <a:rPr lang="en-US" sz="1400" dirty="0" err="1"/>
               <a:t>Jiayong</a:t>
             </a:r>
             <a:r>
-              <a:rPr lang="en-US" sz="1600" dirty="0"/>
-              <a:t> Liua1</a:t>
-            </a:r>
-            <a:endParaRPr lang="en-US" sz="1600" dirty="0">
-              <a:hlinkClick r:id="rId2"/>
-            </a:endParaRPr>
-          </a:p>
-          <a:p>
-            <a:r>
-              <a:rPr lang="en-US" sz="1600" dirty="0"/>
+              <a:rPr lang="en-US" sz="1400" dirty="0"/>
+              <a:t> </a:t>
+            </a:r>
+            <a:r>
+              <a:rPr lang="en-US" sz="1400" dirty="0" err="1"/>
+              <a:t>Liua</a:t>
+            </a:r>
+            <a:r>
+              <a:rPr lang="en-US" sz="1400" dirty="0"/>
+              <a:t>  - </a:t>
+            </a:r>
+            <a:r>
+              <a:rPr lang="en-US" sz="1400" dirty="0">
+                <a:hlinkClick r:id="rId2"/>
+              </a:rPr>
+              <a:t>https://arxiv.org/pdf/1908.01262.pdf</a:t>
+            </a:r>
+            <a:endParaRPr lang="en-US" sz="1400" dirty="0"/>
+          </a:p>
+          <a:p>
+            <a:r>
+              <a:rPr lang="en-US" sz="1400" dirty="0"/>
+              <a:t>* </a:t>
+            </a:r>
+            <a:r>
+              <a:rPr lang="en-US" sz="1400" dirty="0" err="1"/>
+              <a:t>NeuFuzz</a:t>
+            </a:r>
+            <a:r>
+              <a:rPr lang="en-US" sz="1400" dirty="0"/>
+              <a:t>: Efficient Fuzzing With Deep Neural Network – by </a:t>
+            </a:r>
+            <a:r>
+              <a:rPr lang="en-US" sz="1400" dirty="0" err="1"/>
+              <a:t>Yunchao</a:t>
+            </a:r>
+            <a:r>
+              <a:rPr lang="en-US" sz="1400" dirty="0"/>
+              <a:t> Wang; </a:t>
+            </a:r>
+            <a:r>
+              <a:rPr lang="en-US" sz="1400" dirty="0" err="1"/>
+              <a:t>Zehui</a:t>
+            </a:r>
+            <a:r>
+              <a:rPr lang="en-US" sz="1400" dirty="0"/>
+              <a:t> Wu; </a:t>
+            </a:r>
+            <a:r>
+              <a:rPr lang="en-US" sz="1400" dirty="0" err="1"/>
+              <a:t>Qiang</a:t>
+            </a:r>
+            <a:r>
+              <a:rPr lang="en-US" sz="1400" dirty="0"/>
+              <a:t> Wei; </a:t>
+            </a:r>
+            <a:r>
+              <a:rPr lang="en-US" sz="1400" dirty="0" err="1"/>
+              <a:t>Qingxian</a:t>
+            </a:r>
+            <a:r>
+              <a:rPr lang="en-US" sz="1400" dirty="0"/>
+              <a:t> Wang - </a:t>
+            </a:r>
+            <a:r>
+              <a:rPr lang="en-US" sz="1400" dirty="0">
+                <a:hlinkClick r:id="rId3"/>
+              </a:rPr>
+              <a:t>https://ieeexplore.ieee.org/document/8672949</a:t>
+            </a:r>
+            <a:endParaRPr lang="en-US" sz="1400" dirty="0"/>
+          </a:p>
+          <a:p>
+            <a:r>
+              <a:rPr lang="en-US" sz="1400" dirty="0"/>
+              <a:t>* Microsoft - Neural fuzzing: applying Deep Neural Network (DNN) to software security testing … Overall, using neural fuzzing outperformed traditional AFL in most cases.  - </a:t>
+            </a:r>
+            <a:r>
+              <a:rPr lang="en-US" sz="1400" dirty="0">
+                <a:hlinkClick r:id="rId4"/>
+              </a:rPr>
+              <a:t>https://www.microsoft.com/en-us/research/blog/neural-fuzzing/</a:t>
+            </a:r>
+            <a:endParaRPr lang="en-US" sz="1400" dirty="0"/>
+          </a:p>
+          <a:p>
+            <a:r>
+              <a:rPr lang="en-US" sz="1400" dirty="0"/>
+              <a:t>* Coverage-guided Fuzzing for Feedforward Neural Networks – by </a:t>
+            </a:r>
+            <a:r>
+              <a:rPr lang="en-US" sz="1400" dirty="0" err="1"/>
+              <a:t>Xiaofei</a:t>
+            </a:r>
+            <a:r>
+              <a:rPr lang="en-US" sz="1400" dirty="0"/>
+              <a:t> </a:t>
+            </a:r>
+            <a:r>
+              <a:rPr lang="en-US" sz="1400" dirty="0" err="1"/>
+              <a:t>Xie</a:t>
+            </a:r>
+            <a:r>
+              <a:rPr lang="en-US" sz="1400" dirty="0"/>
+              <a:t>; </a:t>
+            </a:r>
+            <a:r>
+              <a:rPr lang="en-US" sz="1400" dirty="0" err="1"/>
+              <a:t>Hongxu</a:t>
+            </a:r>
+            <a:r>
+              <a:rPr lang="en-US" sz="1400" dirty="0"/>
+              <a:t> Chen; Yi Li; Lei Ma; Yang Liu; </a:t>
+            </a:r>
+            <a:r>
+              <a:rPr lang="en-US" sz="1400" dirty="0" err="1"/>
+              <a:t>Jianjun</a:t>
+            </a:r>
+            <a:r>
+              <a:rPr lang="en-US" sz="1400" dirty="0"/>
+              <a:t> Zhao - Singapore &amp; Japan  - </a:t>
+            </a:r>
+            <a:r>
+              <a:rPr lang="en-US" sz="1400" dirty="0">
+                <a:hlinkClick r:id="rId5"/>
+              </a:rPr>
+              <a:t>https://www.ntu.edu.sg/home/yi_li/files/ase19-deephunter.pdf</a:t>
+            </a:r>
+            <a:endParaRPr lang="en-US" sz="1400" dirty="0"/>
+          </a:p>
+          <a:p>
+            <a:r>
+              <a:rPr lang="en-US" sz="1400" dirty="0"/>
+              <a:t>* </a:t>
+            </a:r>
+            <a:r>
+              <a:rPr lang="en-US" sz="1400" dirty="0" err="1"/>
+              <a:t>ReluDiff</a:t>
+            </a:r>
+            <a:r>
+              <a:rPr lang="en-US" sz="1400" dirty="0"/>
+              <a:t>: Differential Verification of Deep Neural Networks – by Brandon Paulsen; </a:t>
+            </a:r>
+            <a:r>
+              <a:rPr lang="en-US" sz="1400" dirty="0" err="1"/>
+              <a:t>Jingbo</a:t>
+            </a:r>
+            <a:r>
+              <a:rPr lang="en-US" sz="1400" dirty="0"/>
+              <a:t> Wang; Chao Wang - </a:t>
+            </a:r>
+            <a:r>
+              <a:rPr lang="en-US" sz="1400" dirty="0">
+                <a:hlinkClick r:id="rId6"/>
+              </a:rPr>
+              <a:t>https://arxiv.org/pdf/2001.03662.pdf</a:t>
+            </a:r>
+            <a:r>
+              <a:rPr lang="en-US" sz="1400" dirty="0"/>
+              <a:t>.      </a:t>
+            </a:r>
+          </a:p>
+          <a:p>
+            <a:r>
+              <a:rPr lang="en-US" sz="1400" dirty="0"/>
+              <a:t>* </a:t>
+            </a:r>
+            <a:r>
+              <a:rPr lang="en-US" sz="1400" dirty="0" err="1"/>
+              <a:t>FuzzerGym</a:t>
+            </a:r>
+            <a:r>
+              <a:rPr lang="en-US" sz="1400" dirty="0"/>
+              <a:t>: A Competitive Framework for Fuzzing and Learning – by William </a:t>
+            </a:r>
+            <a:r>
+              <a:rPr lang="en-US" sz="1400" dirty="0" err="1"/>
+              <a:t>Drozd</a:t>
+            </a:r>
+            <a:r>
+              <a:rPr lang="en-US" sz="1400" dirty="0"/>
+              <a:t> &amp; Michael D. Wagner, CMU - </a:t>
+            </a:r>
+            <a:r>
+              <a:rPr lang="en-US" sz="1400" dirty="0">
+                <a:hlinkClick r:id="rId7"/>
+              </a:rPr>
+              <a:t>https://arxiv.org/pdf/1807.07490.pdf</a:t>
+            </a:r>
+            <a:endParaRPr lang="en-US" sz="1400" dirty="0"/>
+          </a:p>
+          <a:p>
+            <a:r>
+              <a:rPr lang="en-US" sz="1400" dirty="0"/>
+              <a:t>* A systematic review of fuzzing based on machine learning techniques – by Yan </a:t>
+            </a:r>
+            <a:r>
+              <a:rPr lang="en-US" sz="1400" dirty="0" err="1"/>
+              <a:t>Wanga</a:t>
+            </a:r>
+            <a:r>
+              <a:rPr lang="en-US" sz="1400" dirty="0"/>
+              <a:t>, Peng </a:t>
+            </a:r>
+            <a:r>
+              <a:rPr lang="en-US" sz="1400" dirty="0" err="1"/>
+              <a:t>Jiaa</a:t>
+            </a:r>
+            <a:r>
+              <a:rPr lang="en-US" sz="1400" dirty="0"/>
+              <a:t>, </a:t>
+            </a:r>
+            <a:r>
+              <a:rPr lang="en-US" sz="1400" dirty="0" err="1"/>
+              <a:t>Luping</a:t>
+            </a:r>
+            <a:r>
+              <a:rPr lang="en-US" sz="1400" dirty="0"/>
+              <a:t> </a:t>
+            </a:r>
+            <a:r>
+              <a:rPr lang="en-US" sz="1400" dirty="0" err="1"/>
+              <a:t>Liub</a:t>
+            </a:r>
+            <a:r>
+              <a:rPr lang="en-US" sz="1400" dirty="0"/>
+              <a:t>, </a:t>
+            </a:r>
+            <a:r>
+              <a:rPr lang="en-US" sz="1400" dirty="0" err="1"/>
+              <a:t>Jiayong</a:t>
+            </a:r>
+            <a:r>
+              <a:rPr lang="en-US" sz="1400" dirty="0"/>
+              <a:t> </a:t>
+            </a:r>
+            <a:r>
+              <a:rPr lang="en-US" sz="1400" dirty="0" err="1"/>
+              <a:t>Liua</a:t>
+            </a:r>
+            <a:r>
+              <a:rPr lang="en-US" sz="1400" dirty="0"/>
+              <a:t>, China - </a:t>
+            </a:r>
+            <a:r>
+              <a:rPr lang="en-US" sz="1400" dirty="0">
+                <a:hlinkClick r:id="rId2"/>
+              </a:rPr>
+              <a:t>https://arxiv.org/pdf/1908.01262.pdf</a:t>
+            </a:r>
+            <a:r>
+              <a:rPr lang="en-US" sz="1400" dirty="0"/>
+              <a:t>  </a:t>
+            </a:r>
+          </a:p>
+          <a:p>
+            <a:r>
+              <a:rPr lang="en-US" sz="1400" dirty="0"/>
+              <a:t>* The Art, Science, and Engineering of Fuzzing: A Survey (2019) – by Valentin J.M. </a:t>
+            </a:r>
+            <a:r>
+              <a:rPr lang="en-US" sz="1400" dirty="0" err="1"/>
+              <a:t>Man`es</a:t>
+            </a:r>
+            <a:r>
+              <a:rPr lang="en-US" sz="1400" dirty="0"/>
+              <a:t>, </a:t>
+            </a:r>
+            <a:r>
+              <a:rPr lang="en-US" sz="1400" dirty="0" err="1"/>
+              <a:t>HyungSeok</a:t>
+            </a:r>
+            <a:r>
+              <a:rPr lang="en-US" sz="1400" dirty="0"/>
+              <a:t> Han, </a:t>
+            </a:r>
+            <a:r>
+              <a:rPr lang="en-US" sz="1400" dirty="0" err="1"/>
+              <a:t>Choongwoo</a:t>
+            </a:r>
+            <a:r>
+              <a:rPr lang="en-US" sz="1400" dirty="0"/>
+              <a:t> Han, Sang </a:t>
+            </a:r>
+            <a:r>
+              <a:rPr lang="en-US" sz="1400" dirty="0" err="1"/>
+              <a:t>Kil</a:t>
+            </a:r>
+            <a:r>
+              <a:rPr lang="en-US" sz="1400" dirty="0"/>
+              <a:t> Cha, Manuel </a:t>
+            </a:r>
+            <a:r>
+              <a:rPr lang="en-US" sz="1400" dirty="0" err="1"/>
+              <a:t>Egele</a:t>
+            </a:r>
+            <a:r>
+              <a:rPr lang="en-US" sz="1400" dirty="0"/>
+              <a:t>, Edward J. Schwartz, and Maverick Woo - </a:t>
+            </a:r>
+            <a:r>
+              <a:rPr lang="en-US" sz="1400" dirty="0">
+                <a:hlinkClick r:id="rId8"/>
+              </a:rPr>
+              <a:t>https://arxiv.org/pdf/1812.00140.pdf</a:t>
+            </a:r>
+            <a:r>
+              <a:rPr lang="en-US" sz="1400" dirty="0"/>
+              <a:t>  </a:t>
+            </a:r>
+          </a:p>
+          <a:p>
+            <a:r>
+              <a:rPr lang="en-US" sz="1400" dirty="0"/>
+              <a:t>* </a:t>
+            </a:r>
+            <a:r>
+              <a:rPr lang="en-US" sz="1400" dirty="0" err="1"/>
+              <a:t>EnFuzz</a:t>
+            </a:r>
+            <a:r>
+              <a:rPr lang="en-US" sz="1400" dirty="0"/>
+              <a:t>: Ensemble Fuzzing with Seed Synchronization among Diverse </a:t>
+            </a:r>
+            <a:r>
+              <a:rPr lang="en-US" sz="1400" dirty="0" err="1"/>
+              <a:t>Fuzzers</a:t>
+            </a:r>
+            <a:r>
+              <a:rPr lang="en-US" sz="1400" dirty="0"/>
               <a:t> - </a:t>
             </a:r>
             <a:r>
-              <a:rPr lang="en-US" sz="1600" dirty="0">
-                <a:hlinkClick r:id="rId2"/>
-              </a:rPr>
-              <a:t>https://arxiv.org/pdf/1908.01262.pdf</a:t>
-            </a:r>
-            <a:endParaRPr lang="en-US" sz="1600" dirty="0"/>
-          </a:p>
-          <a:p>
-            <a:endParaRPr lang="en-US" sz="1600" dirty="0"/>
-          </a:p>
-          <a:p>
-            <a:r>
-              <a:rPr lang="en-US" sz="1600" dirty="0" err="1"/>
-              <a:t>NeuFuzz</a:t>
-            </a:r>
-            <a:r>
-              <a:rPr lang="en-US" sz="1600" dirty="0"/>
-              <a:t>: Efficient Fuzzing With Deep Neural Network – by </a:t>
-            </a:r>
-            <a:r>
-              <a:rPr lang="en-US" sz="1600" dirty="0" err="1"/>
-              <a:t>Yunchao</a:t>
-            </a:r>
-            <a:r>
-              <a:rPr lang="en-US" sz="1600" dirty="0"/>
-              <a:t> Wang; </a:t>
-            </a:r>
-            <a:r>
-              <a:rPr lang="en-US" sz="1600" dirty="0" err="1"/>
-              <a:t>Zehui</a:t>
-            </a:r>
-            <a:r>
-              <a:rPr lang="en-US" sz="1600" dirty="0"/>
-              <a:t> Wu; </a:t>
-            </a:r>
-            <a:r>
-              <a:rPr lang="en-US" sz="1600" dirty="0" err="1"/>
-              <a:t>Qiang</a:t>
-            </a:r>
-            <a:r>
-              <a:rPr lang="en-US" sz="1600" dirty="0"/>
-              <a:t> Wei; </a:t>
-            </a:r>
-            <a:r>
-              <a:rPr lang="en-US" sz="1600" dirty="0" err="1"/>
-              <a:t>Qingxian</a:t>
-            </a:r>
-            <a:r>
-              <a:rPr lang="en-US" sz="1600" dirty="0"/>
-              <a:t> Wang</a:t>
-            </a:r>
-          </a:p>
-          <a:p>
-            <a:r>
-              <a:rPr lang="en-US" sz="1600" dirty="0"/>
-              <a:t> - </a:t>
-            </a:r>
-            <a:r>
-              <a:rPr lang="en-US" sz="1600" dirty="0">
-                <a:hlinkClick r:id="rId3"/>
-              </a:rPr>
-              <a:t>https://ieeexplore.ieee.org/document/8672949</a:t>
-            </a:r>
-            <a:endParaRPr lang="en-US" sz="1600" dirty="0"/>
-          </a:p>
-          <a:p>
-            <a:endParaRPr lang="en-US" sz="1600" dirty="0"/>
-          </a:p>
-          <a:p>
-            <a:r>
-              <a:rPr lang="en-US" sz="1600" dirty="0"/>
-              <a:t>Microsoft - Neural fuzzing: applying Deep Neural Network (DNN) to software security testing … Overall, using neural fuzzing outperformed traditional AFL in most cases.  - </a:t>
-            </a:r>
-            <a:r>
-              <a:rPr lang="en-US" sz="1600" dirty="0">
-                <a:hlinkClick r:id="rId4"/>
-              </a:rPr>
-              <a:t>https://www.microsoft.com/en-us/research/blog/neural-fuzzing/</a:t>
-            </a:r>
-            <a:endParaRPr lang="en-US" sz="1600" dirty="0"/>
-          </a:p>
-          <a:p>
-            <a:endParaRPr lang="en-US" sz="1600" dirty="0"/>
-          </a:p>
-          <a:p>
-            <a:r>
-              <a:rPr lang="en-US" sz="1600" dirty="0"/>
-              <a:t>Coverage-guided Fuzzing for Feedforward Neural Networks – by </a:t>
-            </a:r>
-            <a:r>
-              <a:rPr lang="en-US" sz="1600" dirty="0" err="1"/>
-              <a:t>Xiaofei</a:t>
-            </a:r>
-            <a:r>
-              <a:rPr lang="en-US" sz="1600" dirty="0"/>
+              <a:rPr lang="en-US" sz="1400" dirty="0">
+                <a:hlinkClick r:id="rId9"/>
+              </a:rPr>
+              <a:t>https://arxiv.org/pdf/1807.00182.pdf</a:t>
+            </a:r>
+            <a:r>
+              <a:rPr lang="en-US" sz="1400" dirty="0"/>
               <a:t> </a:t>
             </a:r>
-            <a:r>
-              <a:rPr lang="en-US" sz="1600" dirty="0" err="1"/>
-              <a:t>Xie</a:t>
-            </a:r>
-            <a:r>
-              <a:rPr lang="en-US" sz="1600" dirty="0"/>
-              <a:t>; </a:t>
-            </a:r>
-            <a:r>
-              <a:rPr lang="en-US" sz="1600" dirty="0" err="1"/>
-              <a:t>Hongxu</a:t>
-            </a:r>
-            <a:r>
-              <a:rPr lang="en-US" sz="1600" dirty="0"/>
-              <a:t> Chen; Yi Li; Lei Ma; Yang Liu; </a:t>
-            </a:r>
-            <a:r>
-              <a:rPr lang="en-US" sz="1600" dirty="0" err="1"/>
-              <a:t>Jianjun</a:t>
-            </a:r>
-            <a:r>
-              <a:rPr lang="en-US" sz="1600" dirty="0"/>
-              <a:t> Zhao - Singapore &amp; Japan  - </a:t>
-            </a:r>
-            <a:r>
-              <a:rPr lang="en-US" sz="1600" dirty="0">
-                <a:hlinkClick r:id="rId5"/>
-              </a:rPr>
-              <a:t>https://www.ntu.edu.sg/home/yi_li/files/ase19-deephunter.pdf</a:t>
-            </a:r>
-            <a:endParaRPr lang="en-US" sz="1600" dirty="0"/>
-          </a:p>
-          <a:p>
-            <a:endParaRPr lang="en-US" sz="1600" dirty="0"/>
-          </a:p>
-          <a:p>
-            <a:r>
-              <a:rPr lang="en-US" sz="1600" dirty="0" err="1"/>
-              <a:t>ReluDiff</a:t>
-            </a:r>
-            <a:r>
-              <a:rPr lang="en-US" sz="1600" dirty="0"/>
-              <a:t>: Differential Verification of Deep Neural Networks – by Brandon Paulsen; </a:t>
-            </a:r>
-            <a:r>
-              <a:rPr lang="en-US" sz="1600" dirty="0" err="1"/>
-              <a:t>Jingbo</a:t>
-            </a:r>
-            <a:r>
-              <a:rPr lang="en-US" sz="1600" dirty="0"/>
-              <a:t> Wang; Chao Wang</a:t>
-            </a:r>
-          </a:p>
-          <a:p>
-            <a:r>
-              <a:rPr lang="en-US" sz="1600" dirty="0"/>
-              <a:t> - </a:t>
-            </a:r>
-            <a:r>
-              <a:rPr lang="en-US" sz="1600" dirty="0">
-                <a:hlinkClick r:id="rId6"/>
-              </a:rPr>
-              <a:t>https://arxiv.org/pdf/2001.03662.pdf</a:t>
-            </a:r>
-            <a:r>
-              <a:rPr lang="en-US" sz="1600" dirty="0"/>
-              <a:t>.      </a:t>
-            </a:r>
-          </a:p>
-          <a:p>
-            <a:endParaRPr lang="en-US" sz="1600" dirty="0"/>
-          </a:p>
-          <a:p>
-            <a:r>
-              <a:rPr lang="en-US" sz="1600" dirty="0" err="1"/>
-              <a:t>FuzzerGym</a:t>
-            </a:r>
-            <a:r>
-              <a:rPr lang="en-US" sz="1600" dirty="0"/>
-              <a:t>: A Competitive Framework for Fuzzing and Learning – by William </a:t>
-            </a:r>
-            <a:r>
-              <a:rPr lang="en-US" sz="1600" dirty="0" err="1"/>
-              <a:t>Drozd</a:t>
-            </a:r>
-            <a:r>
-              <a:rPr lang="en-US" sz="1600" dirty="0"/>
-              <a:t> &amp; Michael D. Wagner, CMU</a:t>
-            </a:r>
-          </a:p>
-          <a:p>
-            <a:r>
-              <a:rPr lang="en-US" sz="1600" dirty="0"/>
-              <a:t> - </a:t>
-            </a:r>
-            <a:r>
-              <a:rPr lang="en-US" sz="1600" dirty="0">
-                <a:hlinkClick r:id="rId7"/>
-              </a:rPr>
-              <a:t>https://arxiv.org/pdf/1807.07490.pdf</a:t>
-            </a:r>
-            <a:endParaRPr lang="en-US" sz="1600" dirty="0"/>
-          </a:p>
-          <a:p>
-            <a:endParaRPr lang="en-US" sz="1600" dirty="0"/>
-          </a:p>
-          <a:p>
-            <a:r>
-              <a:rPr lang="en-US" sz="1600" dirty="0"/>
-              <a:t>A systematic review of fuzzing based on machine learning techniques – by Yan </a:t>
-            </a:r>
-            <a:r>
-              <a:rPr lang="en-US" sz="1600" dirty="0" err="1"/>
-              <a:t>Wanga</a:t>
-            </a:r>
-            <a:r>
-              <a:rPr lang="en-US" sz="1600" dirty="0"/>
-              <a:t>, Peng </a:t>
-            </a:r>
-            <a:r>
-              <a:rPr lang="en-US" sz="1600" dirty="0" err="1"/>
-              <a:t>Jiaa</a:t>
-            </a:r>
-            <a:r>
-              <a:rPr lang="en-US" sz="1600" dirty="0"/>
-              <a:t>, </a:t>
-            </a:r>
-            <a:r>
-              <a:rPr lang="en-US" sz="1600" dirty="0" err="1"/>
-              <a:t>Luping</a:t>
-            </a:r>
-            <a:r>
-              <a:rPr lang="en-US" sz="1600" dirty="0"/>
+          </a:p>
+          <a:p>
+            <a:r>
+              <a:rPr lang="en-US" sz="1400" dirty="0"/>
+              <a:t>* Klee LLVM Execution Engine - </a:t>
+            </a:r>
+            <a:r>
+              <a:rPr lang="en-US" sz="1400" dirty="0">
+                <a:hlinkClick r:id="rId10"/>
+              </a:rPr>
+              <a:t>http://klee.github.io/</a:t>
+            </a:r>
+            <a:r>
+              <a:rPr lang="en-US" sz="1400" dirty="0"/>
               <a:t> </a:t>
             </a:r>
-            <a:r>
-              <a:rPr lang="en-US" sz="1600" dirty="0" err="1"/>
-              <a:t>Liub</a:t>
-            </a:r>
-            <a:r>
-              <a:rPr lang="en-US" sz="1600" dirty="0"/>
-              <a:t>, </a:t>
-            </a:r>
-            <a:r>
-              <a:rPr lang="en-US" sz="1600" dirty="0" err="1"/>
-              <a:t>Jiayong</a:t>
-            </a:r>
-            <a:r>
-              <a:rPr lang="en-US" sz="1600" dirty="0"/>
-              <a:t> </a:t>
-            </a:r>
-            <a:r>
-              <a:rPr lang="en-US" sz="1600" dirty="0" err="1"/>
-              <a:t>Liua</a:t>
-            </a:r>
-            <a:r>
-              <a:rPr lang="en-US" sz="1600" dirty="0"/>
-              <a:t>, China</a:t>
-            </a:r>
-          </a:p>
-          <a:p>
-            <a:r>
-              <a:rPr lang="en-US" sz="1600" dirty="0"/>
-              <a:t> - </a:t>
-            </a:r>
-            <a:r>
-              <a:rPr lang="en-US" sz="1600" dirty="0">
-                <a:hlinkClick r:id="rId2"/>
-              </a:rPr>
-              <a:t>https://arxiv.org/pdf/1908.01262.pdf</a:t>
-            </a:r>
-            <a:r>
-              <a:rPr lang="en-US" sz="1600" dirty="0"/>
+          </a:p>
+          <a:p>
+            <a:r>
+              <a:rPr lang="en-US" sz="1400" dirty="0"/>
+              <a:t>* Microsoft Fuzzing as a service - </a:t>
+            </a:r>
+            <a:r>
+              <a:rPr lang="en-US" sz="1400" dirty="0">
+                <a:hlinkClick r:id="rId11"/>
+              </a:rPr>
+              <a:t>https://www.microsoft.com/en-us/security-risk-detection/</a:t>
+            </a:r>
+            <a:r>
+              <a:rPr lang="en-US" sz="1400" dirty="0"/>
               <a:t>  </a:t>
-            </a:r>
-          </a:p>
-          <a:p>
-            <a:endParaRPr lang="en-US" sz="1600" dirty="0"/>
-          </a:p>
-          <a:p>
-            <a:r>
-              <a:rPr lang="en-US" sz="1600" dirty="0"/>
-              <a:t>The Art, Science, and Engineering of Fuzzing: A Survey (2019) – by Valentin J.M. </a:t>
-            </a:r>
-            <a:r>
-              <a:rPr lang="en-US" sz="1600" dirty="0" err="1"/>
-              <a:t>Man`es</a:t>
-            </a:r>
-            <a:r>
-              <a:rPr lang="en-US" sz="1600" dirty="0"/>
-              <a:t>, </a:t>
-            </a:r>
-            <a:r>
-              <a:rPr lang="en-US" sz="1600" dirty="0" err="1"/>
-              <a:t>HyungSeok</a:t>
-            </a:r>
-            <a:r>
-              <a:rPr lang="en-US" sz="1600" dirty="0"/>
-              <a:t> Han, </a:t>
-            </a:r>
-            <a:r>
-              <a:rPr lang="en-US" sz="1600" dirty="0" err="1"/>
-              <a:t>Choongwoo</a:t>
-            </a:r>
-            <a:r>
-              <a:rPr lang="en-US" sz="1600" dirty="0"/>
-              <a:t> Han, Sang </a:t>
-            </a:r>
-            <a:r>
-              <a:rPr lang="en-US" sz="1600" dirty="0" err="1"/>
-              <a:t>Kil</a:t>
-            </a:r>
-            <a:r>
-              <a:rPr lang="en-US" sz="1600" dirty="0"/>
-              <a:t> Cha, Manuel </a:t>
-            </a:r>
-            <a:r>
-              <a:rPr lang="en-US" sz="1600" dirty="0" err="1"/>
-              <a:t>Egele</a:t>
-            </a:r>
-            <a:r>
-              <a:rPr lang="en-US" sz="1600" dirty="0"/>
-              <a:t>, Edward J. Schwartz, and Maverick Woo - </a:t>
-            </a:r>
-            <a:r>
-              <a:rPr lang="en-US" sz="1600" dirty="0">
-                <a:hlinkClick r:id="rId8"/>
-              </a:rPr>
-              <a:t>https://arxiv.org/pdf/1812.00140.pdf</a:t>
-            </a:r>
-            <a:r>
-              <a:rPr lang="en-US" sz="1600" dirty="0"/>
-              <a:t> </a:t>
             </a:r>
           </a:p>
         </p:txBody>

</xml_diff>